<commit_message>
Import 419 new pure veg menu items from add menu folder (Total: 1,974 items)
</commit_message>
<xml_diff>
--- a/Campus_Mart_Presentation.pptx
+++ b/Campus_Mart_Presentation.pptx
@@ -3226,7 +3226,7 @@
             </a:r>
             <a:br/>
             <a:r>
-              <a:t>• Multi-shop counter order isolation (23 Outlets &amp; 1,555 Pure Veg items)</a:t>
+              <a:t>• Multi-shop counter order isolation (23 Outlets &amp; 1,974+ Pure Veg items)</a:t>
             </a:r>
             <a:br/>
             <a:r>
@@ -4215,7 +4215,7 @@
               </a:defRPr>
             </a:pPr>
             <a:r>
-              <a:t>24/7 Render Cloud API serving 1,555+ items, orders pipeline, split engine &amp; RBAC.</a:t>
+              <a:t>24/7 Render Cloud API serving 1,974+ items, orders pipeline, split engine &amp; RBAC.</a:t>
             </a:r>
           </a:p>
         </p:txBody>
@@ -4310,7 +4310,7 @@
               </a:defRPr>
             </a:pPr>
             <a:r>
-              <a:t>Flexible JSON document persistence for 26 accounts, 1,555 pure veg food items &amp; 23 shops.</a:t>
+              <a:t>Flexible JSON document persistence for 26 accounts, 1,974+ pure veg food items &amp; 23 shops.</a:t>
             </a:r>
           </a:p>
         </p:txBody>
@@ -6665,7 +6665,7 @@
               </a:defRPr>
             </a:pPr>
             <a:r>
-              <a:t>Campus Scale: 1,555 Pure Veg Items Across 23 Outlets</a:t>
+              <a:t>Campus Scale: 1,974+ Pure Veg Items Across 23 Outlets</a:t>
             </a:r>
           </a:p>
         </p:txBody>

</xml_diff>

<commit_message>
Purge all non-veg items, enforce strict Pure Veg guard, apply exact add menu pricing (1,963 Pure Veg items)
</commit_message>
<xml_diff>
--- a/Campus_Mart_Presentation.pptx
+++ b/Campus_Mart_Presentation.pptx
@@ -3226,7 +3226,7 @@
             </a:r>
             <a:br/>
             <a:r>
-              <a:t>• Multi-shop counter order isolation (23 Outlets &amp; 1,974+ Pure Veg items)</a:t>
+              <a:t>• Multi-shop counter order isolation (23 Outlets &amp; 1,963+ Pure Veg items)</a:t>
             </a:r>
             <a:br/>
             <a:r>
@@ -4215,7 +4215,7 @@
               </a:defRPr>
             </a:pPr>
             <a:r>
-              <a:t>24/7 Render Cloud API serving 1,974+ items, orders pipeline, split engine &amp; RBAC.</a:t>
+              <a:t>24/7 Render Cloud API serving 1,963+ items, orders pipeline, split engine &amp; RBAC.</a:t>
             </a:r>
           </a:p>
         </p:txBody>
@@ -4310,7 +4310,7 @@
               </a:defRPr>
             </a:pPr>
             <a:r>
-              <a:t>Flexible JSON document persistence for 26 accounts, 1,974+ pure veg food items &amp; 23 shops.</a:t>
+              <a:t>Flexible JSON document persistence for 26 accounts, 1,963+ pure veg food items &amp; 23 shops.</a:t>
             </a:r>
           </a:p>
         </p:txBody>
@@ -6665,7 +6665,7 @@
               </a:defRPr>
             </a:pPr>
             <a:r>
-              <a:t>Campus Scale: 1,974+ Pure Veg Items Across 23 Outlets</a:t>
+              <a:t>Campus Scale: 1,963+ Pure Veg Items Across 23 Outlets</a:t>
             </a:r>
           </a:p>
         </p:txBody>

</xml_diff>